<commit_message>
Add official Jain University cover page, logo, student names, USNs, and class FBA-03 across report, slides, and app
</commit_message>
<xml_diff>
--- a/MLBA_Assignment_2_Presentation.pptx
+++ b/MLBA_Assignment_2_Presentation.pptx
@@ -3095,16 +3095,40 @@
         <p:nvPr/>
       </p:nvGrpSpPr>
       <p:grpSpPr/>
-      <p:sp>
-        <p:nvSpPr>
-          <p:cNvPr id="2" name="TextBox 1"/>
+      <p:pic>
+        <p:nvPicPr>
+          <p:cNvPr id="2" name="Picture 1" descr="jain_university_logo.png"/>
+          <p:cNvPicPr>
+            <a:picLocks noChangeAspect="1"/>
+          </p:cNvPicPr>
+          <p:nvPr/>
+        </p:nvPicPr>
+        <p:blipFill>
+          <a:blip r:embed="rId2"/>
+          <a:stretch>
+            <a:fillRect/>
+          </a:stretch>
+        </p:blipFill>
+        <p:spPr>
+          <a:xfrm>
+            <a:off x="914400" y="731520"/>
+            <a:ext cx="2286000" cy="1129553"/>
+          </a:xfrm>
+          <a:prstGeom prst="rect">
+            <a:avLst/>
+          </a:prstGeom>
+        </p:spPr>
+      </p:pic>
+      <p:sp>
+        <p:nvSpPr>
+          <p:cNvPr id="3" name="TextBox 2"/>
           <p:cNvSpPr txBox="1"/>
           <p:nvPr/>
         </p:nvSpPr>
         <p:spPr>
           <a:xfrm>
-            <a:off x="1097280" y="1828800"/>
-            <a:ext cx="10058400" cy="3200400"/>
+            <a:off x="914400" y="2011680"/>
+            <a:ext cx="10332720" cy="4389120"/>
           </a:xfrm>
           <a:prstGeom prst="rect">
             <a:avLst/>
@@ -3118,7 +3142,7 @@
           <a:lstStyle/>
           <a:p>
             <a:pPr>
-              <a:defRPr sz="3800" b="1">
+              <a:defRPr sz="3600" b="1">
                 <a:solidFill>
                   <a:srgbClr val="1E3A8A"/>
                 </a:solidFill>
@@ -3127,6 +3151,54 @@
             </a:pPr>
             <a:r>
               <a:t>AI-Driven Credit Default Risk Analyzer</a:t>
+            </a:r>
+          </a:p>
+          <a:p>
+            <a:pPr>
+              <a:spcBef>
+                <a:spcPts val="800"/>
+              </a:spcBef>
+              <a:defRPr sz="1800">
+                <a:solidFill>
+                  <a:srgbClr val="475569"/>
+                </a:solidFill>
+                <a:latin typeface="Arial"/>
+              </a:defRPr>
+            </a:pPr>
+            <a:r>
+              <a:t>Machine Learning Decision Support System for Retail Loan Underwriting</a:t>
+            </a:r>
+          </a:p>
+          <a:p>
+            <a:pPr>
+              <a:spcBef>
+                <a:spcPts val="1800"/>
+              </a:spcBef>
+              <a:defRPr sz="1400" b="1">
+                <a:solidFill>
+                  <a:srgbClr val="1E3A8A"/>
+                </a:solidFill>
+                <a:latin typeface="Arial"/>
+              </a:defRPr>
+            </a:pPr>
+            <a:r>
+              <a:t>JAIN (Deemed-to-be University), Bangalore  •  CMS Business School</a:t>
+            </a:r>
+          </a:p>
+          <a:p>
+            <a:pPr>
+              <a:spcBef>
+                <a:spcPts val="400"/>
+              </a:spcBef>
+              <a:defRPr sz="1300">
+                <a:solidFill>
+                  <a:srgbClr val="0F172A"/>
+                </a:solidFill>
+                <a:latin typeface="Arial"/>
+              </a:defRPr>
+            </a:pPr>
+            <a:r>
+              <a:t>Course: Machine Learning for Business Applications (MLBA)  |  Class: FBA-03</a:t>
             </a:r>
           </a:p>
           <a:p>
@@ -3134,47 +3206,31 @@
               <a:spcBef>
                 <a:spcPts val="1400"/>
               </a:spcBef>
-              <a:defRPr sz="2000">
-                <a:solidFill>
-                  <a:srgbClr val="475569"/>
+              <a:defRPr sz="1400" b="1">
+                <a:solidFill>
+                  <a:srgbClr val="D97706"/>
                 </a:solidFill>
                 <a:latin typeface="Arial"/>
               </a:defRPr>
             </a:pPr>
             <a:r>
-              <a:t>Machine Learning Decision Support System for Retail Loan Underwriting</a:t>
+              <a:t>Submitted by: Akshit Singh (25MBAR0401)  &amp;  Vinay Tiwari (25MBAR0247)</a:t>
             </a:r>
           </a:p>
           <a:p>
             <a:pPr>
               <a:spcBef>
-                <a:spcPts val="2800"/>
+                <a:spcPts val="600"/>
               </a:spcBef>
-              <a:defRPr sz="1500" b="1">
-                <a:solidFill>
-                  <a:srgbClr val="1E3A8A"/>
+              <a:defRPr sz="1200">
+                <a:solidFill>
+                  <a:srgbClr val="475569"/>
                 </a:solidFill>
                 <a:latin typeface="Arial"/>
               </a:defRPr>
             </a:pPr>
             <a:r>
-              <a:t>Course: Machine Learning for Business Applications (MLBA) | MBA – Business Analytics</a:t>
-            </a:r>
-          </a:p>
-          <a:p>
-            <a:pPr>
-              <a:spcBef>
-                <a:spcPts val="800"/>
-              </a:spcBef>
-              <a:defRPr sz="1300">
-                <a:solidFill>
-                  <a:srgbClr val="475569"/>
-                </a:solidFill>
-                <a:latin typeface="Arial"/>
-              </a:defRPr>
-            </a:pPr>
-            <a:r>
-              <a:t>Repository: https://github.com/Akshit226/streamlit-app-MLBA-02-</a:t>
+              <a:t>Live App: https://streamlit-app-mlba-02.streamlit.app  |  GitHub: Akshit226/streamlit-app-MLBA-02-</a:t>
             </a:r>
           </a:p>
         </p:txBody>

</xml_diff>

<commit_message>
Update live Streamlit application URL to active verified deployment link across all documentation, slides, and reports
</commit_message>
<xml_diff>
--- a/MLBA_Assignment_2_Presentation.pptx
+++ b/MLBA_Assignment_2_Presentation.pptx
@@ -3230,7 +3230,7 @@
               </a:defRPr>
             </a:pPr>
             <a:r>
-              <a:t>Live App: https://streamlit-app-mlba-02.streamlit.app  |  GitHub: Akshit226/streamlit-app-MLBA-02-</a:t>
+              <a:t>Live App: https://akshit226-streamlit-app-mlba-02--app-hemxe8.streamlit.app/  |  GitHub: Akshit226/streamlit-app-MLBA-02-</a:t>
             </a:r>
           </a:p>
         </p:txBody>
@@ -4583,7 +4583,7 @@
                 </a:solidFill>
                 <a:latin typeface="Arial"/>
               </a:rPr>
-              <a:t>GitHub: Akshit226/streamlit-app-MLBA-02- | Deployed on Streamlit Community Cloud.</a:t>
+              <a:t>GitHub: Akshit226/streamlit-app-MLBA-02- | Live App: https://akshit226-streamlit-app-mlba-02--app-hemxe8.streamlit.app/</a:t>
             </a:r>
           </a:p>
         </p:txBody>

</xml_diff>